<commit_message>
Add student bank and harden product imports
</commit_message>
<xml_diff>
--- a/docs/video-series/01_Algo_MAX_Короткое_знакомство.pptx
+++ b/docs/video-series/01_Algo_MAX_Короткое_знакомство.pptx
@@ -4057,8 +4057,8 @@
         </p:blipFill>
         <p:spPr>
           <a:xfrm>
-            <a:off x="1464210" y="2029968"/>
-            <a:ext cx="1588715" cy="3438144"/>
+            <a:off x="1619446" y="2029968"/>
+            <a:ext cx="1278242" cy="3438144"/>
           </a:xfrm>
           <a:prstGeom prst="rect">
             <a:avLst/>
@@ -4259,8 +4259,8 @@
         </p:blipFill>
         <p:spPr>
           <a:xfrm>
-            <a:off x="5286402" y="2029968"/>
-            <a:ext cx="1588715" cy="3438144"/>
+            <a:off x="5661211" y="2029968"/>
+            <a:ext cx="839096" cy="3438144"/>
           </a:xfrm>
           <a:prstGeom prst="rect">
             <a:avLst/>

</xml_diff>